<commit_message>
Add analysis scripts, move plots, tweak edge.py
Add an analysis module: Source/analysis/analyze_record.py and README describing aggregation/plotting, outputs (metrics_combined.csv, summaries, analysis_report.md) and current path limitations. Rename/move plot_latency.R and plot_cpu_time.R into Source/analysis. Modify Source/distributed_vlm/edge.py to run image_preprocessing earlier and adjust CPU-sampler startup for embedding/generation. Also add/replace several assignment PDFs and update two PPTX records (binary changes).
</commit_message>
<xml_diff>
--- a/Records/Capstone Progress.pptx
+++ b/Records/Capstone Progress.pptx
@@ -158,580 +158,23 @@
 </p:presentation>
 </file>
 
-<file path=ppt/revisionInfo.xml><?xml version="1.0" encoding="utf-8"?>
-<p1510:revInfo xmlns:a="http://schemas.openxmlformats.org/drawingml/2006/main" xmlns:r="http://schemas.openxmlformats.org/officeDocument/2006/relationships" xmlns:p1510="http://schemas.microsoft.com/office/powerpoint/2015/10/main">
-  <p1510:revLst>
-    <p1510:client id="{F82CF162-E4EB-A648-BB70-BCFC2B7265E3}" v="335" dt="2026-06-19T14:28:49.156"/>
-  </p1510:revLst>
-</p1510:revInfo>
-</file>
-
 <file path=ppt/changesInfos/changesInfo1.xml><?xml version="1.0" encoding="utf-8"?>
 <pc:chgInfo xmlns:a="http://schemas.openxmlformats.org/drawingml/2006/main" xmlns:r="http://schemas.openxmlformats.org/officeDocument/2006/relationships" xmlns:ac="http://schemas.microsoft.com/office/drawing/2013/main/command" xmlns:pc="http://schemas.microsoft.com/office/powerpoint/2013/main/command">
   <pc:docChgLst>
     <pc:chgData name="耀泉 马" userId="19e30af8d5659de2" providerId="LiveId" clId="{C3594856-CEDA-5129-B2AF-7962E3CA4CA3}"/>
     <pc:docChg chg="undo custSel addSld modSld modSection">
-      <pc:chgData name="耀泉 马" userId="19e30af8d5659de2" providerId="LiveId" clId="{C3594856-CEDA-5129-B2AF-7962E3CA4CA3}" dt="2026-06-19T14:28:49.154" v="3889"/>
+      <pc:chgData name="耀泉 马" userId="19e30af8d5659de2" providerId="LiveId" clId="{C3594856-CEDA-5129-B2AF-7962E3CA4CA3}" dt="2026-08-29T15:05:49.399" v="3900" actId="14100"/>
       <pc:docMkLst>
         <pc:docMk/>
       </pc:docMkLst>
-      <pc:sldChg chg="modSp mod">
-        <pc:chgData name="耀泉 马" userId="19e30af8d5659de2" providerId="LiveId" clId="{C3594856-CEDA-5129-B2AF-7962E3CA4CA3}" dt="2026-06-08T11:50:47.862" v="2380" actId="27636"/>
-        <pc:sldMkLst>
-          <pc:docMk/>
-          <pc:sldMk cId="1853872987" sldId="268"/>
-        </pc:sldMkLst>
-        <pc:spChg chg="mod">
-          <ac:chgData name="耀泉 马" userId="19e30af8d5659de2" providerId="LiveId" clId="{C3594856-CEDA-5129-B2AF-7962E3CA4CA3}" dt="2026-06-08T11:50:47.862" v="2380" actId="27636"/>
-          <ac:spMkLst>
-            <pc:docMk/>
-            <pc:sldMk cId="1853872987" sldId="268"/>
-            <ac:spMk id="3" creationId="{CF3649C6-2E5F-3C42-FBEB-C028BFCC91CA}"/>
-          </ac:spMkLst>
-        </pc:spChg>
-      </pc:sldChg>
-      <pc:sldChg chg="addSp delSp modSp new mod modNotesTx">
-        <pc:chgData name="耀泉 马" userId="19e30af8d5659de2" providerId="LiveId" clId="{C3594856-CEDA-5129-B2AF-7962E3CA4CA3}" dt="2026-06-19T14:26:01.210" v="3888"/>
-        <pc:sldMkLst>
-          <pc:docMk/>
-          <pc:sldMk cId="2520208814" sldId="269"/>
-        </pc:sldMkLst>
-        <pc:spChg chg="add mod">
-          <ac:chgData name="耀泉 马" userId="19e30af8d5659de2" providerId="LiveId" clId="{C3594856-CEDA-5129-B2AF-7962E3CA4CA3}" dt="2026-06-19T13:25:51.714" v="3679" actId="14100"/>
-          <ac:spMkLst>
-            <pc:docMk/>
-            <pc:sldMk cId="2520208814" sldId="269"/>
-            <ac:spMk id="2" creationId="{C0103CF7-010A-9605-6372-65DD158F593E}"/>
-          </ac:spMkLst>
-        </pc:spChg>
-        <pc:spChg chg="add mod">
-          <ac:chgData name="耀泉 马" userId="19e30af8d5659de2" providerId="LiveId" clId="{C3594856-CEDA-5129-B2AF-7962E3CA4CA3}" dt="2026-06-19T13:06:36.382" v="3039" actId="1076"/>
-          <ac:spMkLst>
-            <pc:docMk/>
-            <pc:sldMk cId="2520208814" sldId="269"/>
-            <ac:spMk id="3" creationId="{600508CF-B23C-2320-9B99-6D3530F6925F}"/>
-          </ac:spMkLst>
-        </pc:spChg>
-        <pc:spChg chg="add mod">
-          <ac:chgData name="耀泉 马" userId="19e30af8d5659de2" providerId="LiveId" clId="{C3594856-CEDA-5129-B2AF-7962E3CA4CA3}" dt="2026-06-19T13:42:24.934" v="3882" actId="207"/>
-          <ac:spMkLst>
-            <pc:docMk/>
-            <pc:sldMk cId="2520208814" sldId="269"/>
-            <ac:spMk id="4" creationId="{800DEC62-E6AC-226B-8EFB-92D86FD1B8EC}"/>
-          </ac:spMkLst>
-        </pc:spChg>
-        <pc:spChg chg="add mod">
-          <ac:chgData name="耀泉 马" userId="19e30af8d5659de2" providerId="LiveId" clId="{C3594856-CEDA-5129-B2AF-7962E3CA4CA3}" dt="2026-06-19T13:03:13.934" v="2938"/>
-          <ac:spMkLst>
-            <pc:docMk/>
-            <pc:sldMk cId="2520208814" sldId="269"/>
-            <ac:spMk id="5" creationId="{C68AC3DC-12B8-FC65-0AE9-D44FFAB0BE02}"/>
-          </ac:spMkLst>
-        </pc:spChg>
-        <pc:spChg chg="add mod">
-          <ac:chgData name="耀泉 马" userId="19e30af8d5659de2" providerId="LiveId" clId="{C3594856-CEDA-5129-B2AF-7962E3CA4CA3}" dt="2026-06-19T13:27:45.714" v="3732" actId="207"/>
-          <ac:spMkLst>
-            <pc:docMk/>
-            <pc:sldMk cId="2520208814" sldId="269"/>
-            <ac:spMk id="6" creationId="{562FD65B-2831-5B75-DDE7-E479F70FF615}"/>
-          </ac:spMkLst>
-        </pc:spChg>
-        <pc:spChg chg="add mod">
-          <ac:chgData name="耀泉 马" userId="19e30af8d5659de2" providerId="LiveId" clId="{C3594856-CEDA-5129-B2AF-7962E3CA4CA3}" dt="2026-06-19T13:27:48.097" v="3733" actId="207"/>
-          <ac:spMkLst>
-            <pc:docMk/>
-            <pc:sldMk cId="2520208814" sldId="269"/>
-            <ac:spMk id="7" creationId="{6196E635-7892-FD55-7648-999E25750D33}"/>
-          </ac:spMkLst>
-        </pc:spChg>
-        <pc:spChg chg="add mod">
-          <ac:chgData name="耀泉 马" userId="19e30af8d5659de2" providerId="LiveId" clId="{C3594856-CEDA-5129-B2AF-7962E3CA4CA3}" dt="2026-06-19T13:31:56.069" v="3749" actId="207"/>
-          <ac:spMkLst>
-            <pc:docMk/>
-            <pc:sldMk cId="2520208814" sldId="269"/>
-            <ac:spMk id="8" creationId="{BB2F7F78-6017-6895-D183-6098780E4EBE}"/>
-          </ac:spMkLst>
-        </pc:spChg>
-        <pc:spChg chg="add mod">
-          <ac:chgData name="耀泉 马" userId="19e30af8d5659de2" providerId="LiveId" clId="{C3594856-CEDA-5129-B2AF-7962E3CA4CA3}" dt="2026-06-19T13:26:15.128" v="3683" actId="14100"/>
-          <ac:spMkLst>
-            <pc:docMk/>
-            <pc:sldMk cId="2520208814" sldId="269"/>
-            <ac:spMk id="9" creationId="{CB4F2288-D054-E3E0-4447-79AA5EFEECE4}"/>
-          </ac:spMkLst>
-        </pc:spChg>
-        <pc:spChg chg="add mod">
-          <ac:chgData name="耀泉 马" userId="19e30af8d5659de2" providerId="LiveId" clId="{C3594856-CEDA-5129-B2AF-7962E3CA4CA3}" dt="2026-06-19T13:42:55.790" v="3883" actId="1076"/>
-          <ac:spMkLst>
-            <pc:docMk/>
-            <pc:sldMk cId="2520208814" sldId="269"/>
-            <ac:spMk id="10" creationId="{C4FC5301-058C-2D64-8926-4F22C083AC6B}"/>
-          </ac:spMkLst>
-        </pc:spChg>
-        <pc:spChg chg="add mod">
-          <ac:chgData name="耀泉 马" userId="19e30af8d5659de2" providerId="LiveId" clId="{C3594856-CEDA-5129-B2AF-7962E3CA4CA3}" dt="2026-06-19T13:40:33.263" v="3858" actId="255"/>
-          <ac:spMkLst>
-            <pc:docMk/>
-            <pc:sldMk cId="2520208814" sldId="269"/>
-            <ac:spMk id="11" creationId="{BEA28A49-F96A-FE70-2BFF-A4ED038F8070}"/>
-          </ac:spMkLst>
-        </pc:spChg>
-        <pc:spChg chg="add mod">
-          <ac:chgData name="耀泉 马" userId="19e30af8d5659de2" providerId="LiveId" clId="{C3594856-CEDA-5129-B2AF-7962E3CA4CA3}" dt="2026-06-19T13:40:40.371" v="3861" actId="255"/>
-          <ac:spMkLst>
-            <pc:docMk/>
-            <pc:sldMk cId="2520208814" sldId="269"/>
-            <ac:spMk id="12" creationId="{D2D9F0AE-F923-949B-E2AD-81F0E7C78842}"/>
-          </ac:spMkLst>
-        </pc:spChg>
-        <pc:spChg chg="add mod">
-          <ac:chgData name="耀泉 马" userId="19e30af8d5659de2" providerId="LiveId" clId="{C3594856-CEDA-5129-B2AF-7962E3CA4CA3}" dt="2026-06-19T13:32:20.891" v="3757" actId="207"/>
-          <ac:spMkLst>
-            <pc:docMk/>
-            <pc:sldMk cId="2520208814" sldId="269"/>
-            <ac:spMk id="13" creationId="{92A36B02-156F-0D06-B853-E597C2E11D77}"/>
-          </ac:spMkLst>
-        </pc:spChg>
-        <pc:spChg chg="add mod">
-          <ac:chgData name="耀泉 马" userId="19e30af8d5659de2" providerId="LiveId" clId="{C3594856-CEDA-5129-B2AF-7962E3CA4CA3}" dt="2026-06-19T13:39:40.098" v="3851"/>
-          <ac:spMkLst>
-            <pc:docMk/>
-            <pc:sldMk cId="2520208814" sldId="269"/>
-            <ac:spMk id="14" creationId="{7BDF42CB-7520-2725-2E9D-0EF75325EBA3}"/>
-          </ac:spMkLst>
-        </pc:spChg>
-        <pc:spChg chg="add mod">
-          <ac:chgData name="耀泉 马" userId="19e30af8d5659de2" providerId="LiveId" clId="{C3594856-CEDA-5129-B2AF-7962E3CA4CA3}" dt="2026-06-19T13:33:31.456" v="3779" actId="1036"/>
-          <ac:spMkLst>
-            <pc:docMk/>
-            <pc:sldMk cId="2520208814" sldId="269"/>
-            <ac:spMk id="15" creationId="{344F0FAE-5C0E-351B-9E24-016E839CE96B}"/>
-          </ac:spMkLst>
-        </pc:spChg>
-        <pc:spChg chg="add del mod">
-          <ac:chgData name="耀泉 马" userId="19e30af8d5659de2" providerId="LiveId" clId="{C3594856-CEDA-5129-B2AF-7962E3CA4CA3}" dt="2026-06-19T13:32:55.980" v="3761" actId="478"/>
-          <ac:spMkLst>
-            <pc:docMk/>
-            <pc:sldMk cId="2520208814" sldId="269"/>
-            <ac:spMk id="16" creationId="{7E136E13-0C5B-D2CA-E9A2-AFEE701036C8}"/>
-          </ac:spMkLst>
-        </pc:spChg>
-        <pc:spChg chg="add mod">
-          <ac:chgData name="耀泉 马" userId="19e30af8d5659de2" providerId="LiveId" clId="{C3594856-CEDA-5129-B2AF-7962E3CA4CA3}" dt="2026-06-19T13:18:43.909" v="3585" actId="207"/>
-          <ac:spMkLst>
-            <pc:docMk/>
-            <pc:sldMk cId="2520208814" sldId="269"/>
-            <ac:spMk id="20" creationId="{2F069AE7-6914-091A-5944-3D166CFEAFFB}"/>
-          </ac:spMkLst>
-        </pc:spChg>
-        <pc:spChg chg="add del mod">
-          <ac:chgData name="耀泉 马" userId="19e30af8d5659de2" providerId="LiveId" clId="{C3594856-CEDA-5129-B2AF-7962E3CA4CA3}" dt="2026-06-19T13:32:11.305" v="3754"/>
-          <ac:spMkLst>
-            <pc:docMk/>
-            <pc:sldMk cId="2520208814" sldId="269"/>
-            <ac:spMk id="21" creationId="{57A00574-B926-2F2B-7F44-F05A248E8E2A}"/>
-          </ac:spMkLst>
-        </pc:spChg>
-        <pc:spChg chg="add mod">
-          <ac:chgData name="耀泉 马" userId="19e30af8d5659de2" providerId="LiveId" clId="{C3594856-CEDA-5129-B2AF-7962E3CA4CA3}" dt="2026-06-19T13:41:59.080" v="3879"/>
-          <ac:spMkLst>
-            <pc:docMk/>
-            <pc:sldMk cId="2520208814" sldId="269"/>
-            <ac:spMk id="22" creationId="{C4F77A03-0511-DF02-531E-73DF0C518CAA}"/>
-          </ac:spMkLst>
-        </pc:spChg>
-        <pc:spChg chg="add mod">
-          <ac:chgData name="耀泉 马" userId="19e30af8d5659de2" providerId="LiveId" clId="{C3594856-CEDA-5129-B2AF-7962E3CA4CA3}" dt="2026-06-19T13:21:33.776" v="3636"/>
-          <ac:spMkLst>
-            <pc:docMk/>
-            <pc:sldMk cId="2520208814" sldId="269"/>
-            <ac:spMk id="38" creationId="{01DE6AED-8624-7B24-095D-1AA72E4DFC70}"/>
-          </ac:spMkLst>
-        </pc:spChg>
-        <pc:spChg chg="add mod">
-          <ac:chgData name="耀泉 马" userId="19e30af8d5659de2" providerId="LiveId" clId="{C3594856-CEDA-5129-B2AF-7962E3CA4CA3}" dt="2026-06-19T13:33:02.492" v="3762" actId="14100"/>
-          <ac:spMkLst>
-            <pc:docMk/>
-            <pc:sldMk cId="2520208814" sldId="269"/>
-            <ac:spMk id="52" creationId="{326142E4-2E29-F6BB-DE21-03E7F29A078B}"/>
-          </ac:spMkLst>
-        </pc:spChg>
-        <pc:spChg chg="add mod">
-          <ac:chgData name="耀泉 马" userId="19e30af8d5659de2" providerId="LiveId" clId="{C3594856-CEDA-5129-B2AF-7962E3CA4CA3}" dt="2026-06-19T13:27:31.077" v="3730" actId="1076"/>
-          <ac:spMkLst>
-            <pc:docMk/>
-            <pc:sldMk cId="2520208814" sldId="269"/>
-            <ac:spMk id="54" creationId="{BF1C40E7-65AD-3A09-6007-EBFB84481D77}"/>
-          </ac:spMkLst>
-        </pc:spChg>
-        <pc:spChg chg="add mod">
-          <ac:chgData name="耀泉 马" userId="19e30af8d5659de2" providerId="LiveId" clId="{C3594856-CEDA-5129-B2AF-7962E3CA4CA3}" dt="2026-06-19T14:26:01.210" v="3888"/>
-          <ac:spMkLst>
-            <pc:docMk/>
-            <pc:sldMk cId="2520208814" sldId="269"/>
-            <ac:spMk id="55" creationId="{323F2407-5CF2-1429-9018-8E8CC605CD48}"/>
-          </ac:spMkLst>
-        </pc:spChg>
-        <pc:spChg chg="add mod">
-          <ac:chgData name="耀泉 马" userId="19e30af8d5659de2" providerId="LiveId" clId="{C3594856-CEDA-5129-B2AF-7962E3CA4CA3}" dt="2026-06-19T13:33:10.846" v="3766"/>
-          <ac:spMkLst>
-            <pc:docMk/>
-            <pc:sldMk cId="2520208814" sldId="269"/>
-            <ac:spMk id="56" creationId="{2F4D464E-EAD0-7B28-B5ED-6E038BEE350B}"/>
-          </ac:spMkLst>
-        </pc:spChg>
-        <pc:spChg chg="add mod">
-          <ac:chgData name="耀泉 马" userId="19e30af8d5659de2" providerId="LiveId" clId="{C3594856-CEDA-5129-B2AF-7962E3CA4CA3}" dt="2026-06-19T13:41:43.983" v="3877" actId="207"/>
-          <ac:spMkLst>
-            <pc:docMk/>
-            <pc:sldMk cId="2520208814" sldId="269"/>
-            <ac:spMk id="63" creationId="{50FF725E-0EE5-FC42-F0FC-B302913FB43F}"/>
-          </ac:spMkLst>
-        </pc:spChg>
-        <pc:spChg chg="add del mod">
-          <ac:chgData name="耀泉 马" userId="19e30af8d5659de2" providerId="LiveId" clId="{C3594856-CEDA-5129-B2AF-7962E3CA4CA3}" dt="2026-06-19T13:01:33.939" v="2917" actId="478"/>
-          <ac:spMkLst>
-            <pc:docMk/>
-            <pc:sldMk cId="2520208814" sldId="269"/>
-            <ac:spMk id="96" creationId="{BCCF3236-A221-B990-DA6A-474540A36AC7}"/>
-          </ac:spMkLst>
-        </pc:spChg>
-        <pc:spChg chg="add del mod">
-          <ac:chgData name="耀泉 马" userId="19e30af8d5659de2" providerId="LiveId" clId="{C3594856-CEDA-5129-B2AF-7962E3CA4CA3}" dt="2026-06-19T13:01:33.939" v="2917" actId="478"/>
-          <ac:spMkLst>
-            <pc:docMk/>
-            <pc:sldMk cId="2520208814" sldId="269"/>
-            <ac:spMk id="116" creationId="{63997B99-74B0-040E-B52E-D4343DB5A519}"/>
-          </ac:spMkLst>
-        </pc:spChg>
-        <pc:spChg chg="add del mod">
-          <ac:chgData name="耀泉 马" userId="19e30af8d5659de2" providerId="LiveId" clId="{C3594856-CEDA-5129-B2AF-7962E3CA4CA3}" dt="2026-06-19T13:01:33.939" v="2917" actId="478"/>
-          <ac:spMkLst>
-            <pc:docMk/>
-            <pc:sldMk cId="2520208814" sldId="269"/>
-            <ac:spMk id="141" creationId="{E58912BB-F314-8295-1A6C-5CB7AAC9F65F}"/>
-          </ac:spMkLst>
-        </pc:spChg>
-        <pc:spChg chg="add del mod">
-          <ac:chgData name="耀泉 马" userId="19e30af8d5659de2" providerId="LiveId" clId="{C3594856-CEDA-5129-B2AF-7962E3CA4CA3}" dt="2026-06-19T13:01:33.939" v="2917" actId="478"/>
-          <ac:spMkLst>
-            <pc:docMk/>
-            <pc:sldMk cId="2520208814" sldId="269"/>
-            <ac:spMk id="145" creationId="{F469385C-D6E3-CE87-4D9A-592AAFD329E4}"/>
-          </ac:spMkLst>
-        </pc:spChg>
-        <pc:spChg chg="add del mod">
-          <ac:chgData name="耀泉 马" userId="19e30af8d5659de2" providerId="LiveId" clId="{C3594856-CEDA-5129-B2AF-7962E3CA4CA3}" dt="2026-06-19T13:01:33.939" v="2917" actId="478"/>
-          <ac:spMkLst>
-            <pc:docMk/>
-            <pc:sldMk cId="2520208814" sldId="269"/>
-            <ac:spMk id="147" creationId="{FA9691AB-BFEC-1BE3-5A87-305AF1D91BB3}"/>
-          </ac:spMkLst>
-        </pc:spChg>
-        <pc:spChg chg="add del mod">
-          <ac:chgData name="耀泉 马" userId="19e30af8d5659de2" providerId="LiveId" clId="{C3594856-CEDA-5129-B2AF-7962E3CA4CA3}" dt="2026-06-19T13:01:33.939" v="2917" actId="478"/>
-          <ac:spMkLst>
-            <pc:docMk/>
-            <pc:sldMk cId="2520208814" sldId="269"/>
-            <ac:spMk id="155" creationId="{A612EF7E-0F09-5D74-B404-DAD3FB3A3D85}"/>
-          </ac:spMkLst>
-        </pc:spChg>
-        <pc:spChg chg="add del mod">
-          <ac:chgData name="耀泉 马" userId="19e30af8d5659de2" providerId="LiveId" clId="{C3594856-CEDA-5129-B2AF-7962E3CA4CA3}" dt="2026-06-19T13:01:33.939" v="2917" actId="478"/>
-          <ac:spMkLst>
-            <pc:docMk/>
-            <pc:sldMk cId="2520208814" sldId="269"/>
-            <ac:spMk id="156" creationId="{A7CCDA6B-8DAC-6779-0300-D1ABD7723CD6}"/>
-          </ac:spMkLst>
-        </pc:spChg>
-        <pc:spChg chg="add del mod">
-          <ac:chgData name="耀泉 马" userId="19e30af8d5659de2" providerId="LiveId" clId="{C3594856-CEDA-5129-B2AF-7962E3CA4CA3}" dt="2026-06-19T13:01:33.939" v="2917" actId="478"/>
-          <ac:spMkLst>
-            <pc:docMk/>
-            <pc:sldMk cId="2520208814" sldId="269"/>
-            <ac:spMk id="159" creationId="{4241A81B-9F61-A630-8B8A-BE611C0C9531}"/>
-          </ac:spMkLst>
-        </pc:spChg>
-        <pc:spChg chg="add del mod">
-          <ac:chgData name="耀泉 马" userId="19e30af8d5659de2" providerId="LiveId" clId="{C3594856-CEDA-5129-B2AF-7962E3CA4CA3}" dt="2026-06-19T13:01:33.939" v="2917" actId="478"/>
-          <ac:spMkLst>
-            <pc:docMk/>
-            <pc:sldMk cId="2520208814" sldId="269"/>
-            <ac:spMk id="160" creationId="{C66CD70B-3997-E535-C310-3F86D9F14847}"/>
-          </ac:spMkLst>
-        </pc:spChg>
-        <pc:spChg chg="add del mod">
-          <ac:chgData name="耀泉 马" userId="19e30af8d5659de2" providerId="LiveId" clId="{C3594856-CEDA-5129-B2AF-7962E3CA4CA3}" dt="2026-06-19T13:01:33.939" v="2917" actId="478"/>
-          <ac:spMkLst>
-            <pc:docMk/>
-            <pc:sldMk cId="2520208814" sldId="269"/>
-            <ac:spMk id="196" creationId="{440EBA3A-420D-42CD-11AE-51A627FB67B3}"/>
-          </ac:spMkLst>
-        </pc:spChg>
-        <pc:cxnChg chg="add del mod">
-          <ac:chgData name="耀泉 马" userId="19e30af8d5659de2" providerId="LiveId" clId="{C3594856-CEDA-5129-B2AF-7962E3CA4CA3}" dt="2026-06-19T13:40:47.763" v="3862" actId="478"/>
-          <ac:cxnSpMkLst>
-            <pc:docMk/>
-            <pc:sldMk cId="2520208814" sldId="269"/>
-            <ac:cxnSpMk id="18" creationId="{E47F1B9B-EAED-3BB9-ADC1-D1BD49602A21}"/>
-          </ac:cxnSpMkLst>
-        </pc:cxnChg>
-        <pc:cxnChg chg="add del mod">
-          <ac:chgData name="耀泉 马" userId="19e30af8d5659de2" providerId="LiveId" clId="{C3594856-CEDA-5129-B2AF-7962E3CA4CA3}" dt="2026-06-19T13:19:32.775" v="3602" actId="11529"/>
-          <ac:cxnSpMkLst>
-            <pc:docMk/>
-            <pc:sldMk cId="2520208814" sldId="269"/>
-            <ac:cxnSpMk id="24" creationId="{22B72614-22DA-34B6-E492-61DC75C247B4}"/>
-          </ac:cxnSpMkLst>
-        </pc:cxnChg>
-        <pc:cxnChg chg="add mod">
-          <ac:chgData name="耀泉 马" userId="19e30af8d5659de2" providerId="LiveId" clId="{C3594856-CEDA-5129-B2AF-7962E3CA4CA3}" dt="2026-06-19T13:26:22.545" v="3685" actId="1076"/>
-          <ac:cxnSpMkLst>
-            <pc:docMk/>
-            <pc:sldMk cId="2520208814" sldId="269"/>
-            <ac:cxnSpMk id="26" creationId="{786AC854-6257-81CA-6F9F-99EE40C4E8C9}"/>
-          </ac:cxnSpMkLst>
-        </pc:cxnChg>
-        <pc:cxnChg chg="add mod">
-          <ac:chgData name="耀泉 马" userId="19e30af8d5659de2" providerId="LiveId" clId="{C3594856-CEDA-5129-B2AF-7962E3CA4CA3}" dt="2026-06-19T13:21:09.140" v="3633" actId="1036"/>
-          <ac:cxnSpMkLst>
-            <pc:docMk/>
-            <pc:sldMk cId="2520208814" sldId="269"/>
-            <ac:cxnSpMk id="28" creationId="{96F68F3E-BC61-00A9-A080-1D757F3BF57C}"/>
-          </ac:cxnSpMkLst>
-        </pc:cxnChg>
-        <pc:cxnChg chg="add mod">
-          <ac:chgData name="耀泉 马" userId="19e30af8d5659de2" providerId="LiveId" clId="{C3594856-CEDA-5129-B2AF-7962E3CA4CA3}" dt="2026-06-19T13:21:14.150" v="3634" actId="14100"/>
-          <ac:cxnSpMkLst>
-            <pc:docMk/>
-            <pc:sldMk cId="2520208814" sldId="269"/>
-            <ac:cxnSpMk id="36" creationId="{9F798EA7-D61B-DB3E-6DC1-65A9177A72E9}"/>
-          </ac:cxnSpMkLst>
-        </pc:cxnChg>
-        <pc:cxnChg chg="add mod">
-          <ac:chgData name="耀泉 马" userId="19e30af8d5659de2" providerId="LiveId" clId="{C3594856-CEDA-5129-B2AF-7962E3CA4CA3}" dt="2026-06-19T13:22:27.339" v="3646" actId="692"/>
-          <ac:cxnSpMkLst>
-            <pc:docMk/>
-            <pc:sldMk cId="2520208814" sldId="269"/>
-            <ac:cxnSpMk id="40" creationId="{E246F46A-45FB-7250-01D3-2E2C16DA8890}"/>
-          </ac:cxnSpMkLst>
-        </pc:cxnChg>
-        <pc:cxnChg chg="add mod">
-          <ac:chgData name="耀泉 马" userId="19e30af8d5659de2" providerId="LiveId" clId="{C3594856-CEDA-5129-B2AF-7962E3CA4CA3}" dt="2026-06-19T13:22:27.339" v="3646" actId="692"/>
-          <ac:cxnSpMkLst>
-            <pc:docMk/>
-            <pc:sldMk cId="2520208814" sldId="269"/>
-            <ac:cxnSpMk id="42" creationId="{51B349F9-BE9F-C73A-BAE7-F77FF38385C5}"/>
-          </ac:cxnSpMkLst>
-        </pc:cxnChg>
-        <pc:cxnChg chg="add mod">
-          <ac:chgData name="耀泉 马" userId="19e30af8d5659de2" providerId="LiveId" clId="{C3594856-CEDA-5129-B2AF-7962E3CA4CA3}" dt="2026-06-19T13:35:09.106" v="3787" actId="14100"/>
-          <ac:cxnSpMkLst>
-            <pc:docMk/>
-            <pc:sldMk cId="2520208814" sldId="269"/>
-            <ac:cxnSpMk id="45" creationId="{50833B81-2426-3C5C-DC16-D8888C5A043F}"/>
-          </ac:cxnSpMkLst>
-        </pc:cxnChg>
-        <pc:cxnChg chg="add mod">
-          <ac:chgData name="耀泉 马" userId="19e30af8d5659de2" providerId="LiveId" clId="{C3594856-CEDA-5129-B2AF-7962E3CA4CA3}" dt="2026-06-19T13:35:09.106" v="3787" actId="14100"/>
-          <ac:cxnSpMkLst>
-            <pc:docMk/>
-            <pc:sldMk cId="2520208814" sldId="269"/>
-            <ac:cxnSpMk id="46" creationId="{EE5DC73B-7EB7-5AAB-571C-D1B9FCA3EAEF}"/>
-          </ac:cxnSpMkLst>
-        </pc:cxnChg>
-        <pc:cxnChg chg="add del mod">
-          <ac:chgData name="耀泉 马" userId="19e30af8d5659de2" providerId="LiveId" clId="{C3594856-CEDA-5129-B2AF-7962E3CA4CA3}" dt="2026-06-19T13:23:56.966" v="3665" actId="478"/>
-          <ac:cxnSpMkLst>
-            <pc:docMk/>
-            <pc:sldMk cId="2520208814" sldId="269"/>
-            <ac:cxnSpMk id="49" creationId="{97FD828F-CF37-980A-9463-FBB02E7A0E30}"/>
-          </ac:cxnSpMkLst>
-        </pc:cxnChg>
-        <pc:cxnChg chg="add">
-          <ac:chgData name="耀泉 马" userId="19e30af8d5659de2" providerId="LiveId" clId="{C3594856-CEDA-5129-B2AF-7962E3CA4CA3}" dt="2026-06-19T13:33:42.202" v="3780" actId="11529"/>
-          <ac:cxnSpMkLst>
-            <pc:docMk/>
-            <pc:sldMk cId="2520208814" sldId="269"/>
-            <ac:cxnSpMk id="58" creationId="{4F0F8685-ABD7-12A0-11C0-D20C3237C16B}"/>
-          </ac:cxnSpMkLst>
-        </pc:cxnChg>
-      </pc:sldChg>
-      <pc:sldChg chg="modSp new mod">
-        <pc:chgData name="耀泉 马" userId="19e30af8d5659de2" providerId="LiveId" clId="{C3594856-CEDA-5129-B2AF-7962E3CA4CA3}" dt="2026-06-08T11:53:58.077" v="2455" actId="20578"/>
-        <pc:sldMkLst>
-          <pc:docMk/>
-          <pc:sldMk cId="582110372" sldId="270"/>
-        </pc:sldMkLst>
-        <pc:spChg chg="mod">
-          <ac:chgData name="耀泉 马" userId="19e30af8d5659de2" providerId="LiveId" clId="{C3594856-CEDA-5129-B2AF-7962E3CA4CA3}" dt="2026-06-08T11:39:06.777" v="1942" actId="20577"/>
-          <ac:spMkLst>
-            <pc:docMk/>
-            <pc:sldMk cId="582110372" sldId="270"/>
-            <ac:spMk id="2" creationId="{F9AB6D9C-F7FF-AE3E-645D-471C1C9E7E98}"/>
-          </ac:spMkLst>
-        </pc:spChg>
-        <pc:spChg chg="mod">
-          <ac:chgData name="耀泉 马" userId="19e30af8d5659de2" providerId="LiveId" clId="{C3594856-CEDA-5129-B2AF-7962E3CA4CA3}" dt="2026-06-08T11:53:58.077" v="2455" actId="20578"/>
-          <ac:spMkLst>
-            <pc:docMk/>
-            <pc:sldMk cId="582110372" sldId="270"/>
-            <ac:spMk id="3" creationId="{A49C73BD-704C-815A-3932-EA5429BDE1A4}"/>
-          </ac:spMkLst>
-        </pc:spChg>
-      </pc:sldChg>
       <pc:sldChg chg="addSp delSp modSp add mod">
-        <pc:chgData name="耀泉 马" userId="19e30af8d5659de2" providerId="LiveId" clId="{C3594856-CEDA-5129-B2AF-7962E3CA4CA3}" dt="2026-06-19T14:26:00.614" v="3887" actId="14100"/>
+        <pc:chgData name="耀泉 马" userId="19e30af8d5659de2" providerId="LiveId" clId="{C3594856-CEDA-5129-B2AF-7962E3CA4CA3}" dt="2026-08-29T15:05:49.399" v="3900" actId="14100"/>
         <pc:sldMkLst>
           <pc:docMk/>
           <pc:sldMk cId="3818938006" sldId="271"/>
         </pc:sldMkLst>
-        <pc:spChg chg="add del mod">
-          <ac:chgData name="耀泉 马" userId="19e30af8d5659de2" providerId="LiveId" clId="{C3594856-CEDA-5129-B2AF-7962E3CA4CA3}" dt="2026-06-19T12:55:36.762" v="2914"/>
-          <ac:spMkLst>
-            <pc:docMk/>
-            <pc:sldMk cId="3818938006" sldId="271"/>
-            <ac:spMk id="3" creationId="{E2A1DE53-B3F7-5C8D-2363-CF9983838094}"/>
-          </ac:spMkLst>
-        </pc:spChg>
-        <pc:spChg chg="add mod">
-          <ac:chgData name="耀泉 马" userId="19e30af8d5659de2" providerId="LiveId" clId="{C3594856-CEDA-5129-B2AF-7962E3CA4CA3}" dt="2026-06-19T12:53:07.133" v="2897" actId="14100"/>
-          <ac:spMkLst>
-            <pc:docMk/>
-            <pc:sldMk cId="3818938006" sldId="271"/>
-            <ac:spMk id="12" creationId="{6DB89B6A-CF76-088C-B370-4E503C8C0A02}"/>
-          </ac:spMkLst>
-        </pc:spChg>
-        <pc:spChg chg="add mod">
-          <ac:chgData name="耀泉 马" userId="19e30af8d5659de2" providerId="LiveId" clId="{C3594856-CEDA-5129-B2AF-7962E3CA4CA3}" dt="2026-06-13T10:44:50.452" v="2851" actId="1076"/>
-          <ac:spMkLst>
-            <pc:docMk/>
-            <pc:sldMk cId="3818938006" sldId="271"/>
-            <ac:spMk id="16" creationId="{537A21F0-EE18-28CA-8BD1-B8DE0D5E7447}"/>
-          </ac:spMkLst>
-        </pc:spChg>
-        <pc:spChg chg="add mod">
-          <ac:chgData name="耀泉 马" userId="19e30af8d5659de2" providerId="LiveId" clId="{C3594856-CEDA-5129-B2AF-7962E3CA4CA3}" dt="2026-06-13T10:44:42.379" v="2849" actId="1035"/>
-          <ac:spMkLst>
-            <pc:docMk/>
-            <pc:sldMk cId="3818938006" sldId="271"/>
-            <ac:spMk id="18" creationId="{777DE5AC-CEB6-DFB9-C82B-31FFBD25B66B}"/>
-          </ac:spMkLst>
-        </pc:spChg>
-        <pc:spChg chg="add mod">
-          <ac:chgData name="耀泉 马" userId="19e30af8d5659de2" providerId="LiveId" clId="{C3594856-CEDA-5129-B2AF-7962E3CA4CA3}" dt="2026-06-13T10:37:05.411" v="2614" actId="167"/>
-          <ac:spMkLst>
-            <pc:docMk/>
-            <pc:sldMk cId="3818938006" sldId="271"/>
-            <ac:spMk id="22" creationId="{3CE88015-D4D0-DE32-5512-844195C34250}"/>
-          </ac:spMkLst>
-        </pc:spChg>
-        <pc:spChg chg="add mod">
-          <ac:chgData name="耀泉 马" userId="19e30af8d5659de2" providerId="LiveId" clId="{C3594856-CEDA-5129-B2AF-7962E3CA4CA3}" dt="2026-06-13T10:45:25.470" v="2859" actId="14100"/>
-          <ac:spMkLst>
-            <pc:docMk/>
-            <pc:sldMk cId="3818938006" sldId="271"/>
-            <ac:spMk id="23" creationId="{FAACC1F9-DB66-952B-7DD9-6ABBF3374BD0}"/>
-          </ac:spMkLst>
-        </pc:spChg>
-        <pc:spChg chg="add mod">
-          <ac:chgData name="耀泉 马" userId="19e30af8d5659de2" providerId="LiveId" clId="{C3594856-CEDA-5129-B2AF-7962E3CA4CA3}" dt="2026-06-13T10:44:47.770" v="2850" actId="1076"/>
-          <ac:spMkLst>
-            <pc:docMk/>
-            <pc:sldMk cId="3818938006" sldId="271"/>
-            <ac:spMk id="24" creationId="{FA858E0E-CDC7-61E8-D134-9A02AEC223FD}"/>
-          </ac:spMkLst>
-        </pc:spChg>
-        <pc:spChg chg="add mod">
-          <ac:chgData name="耀泉 马" userId="19e30af8d5659de2" providerId="LiveId" clId="{C3594856-CEDA-5129-B2AF-7962E3CA4CA3}" dt="2026-06-13T10:38:21.366" v="2630" actId="14100"/>
-          <ac:spMkLst>
-            <pc:docMk/>
-            <pc:sldMk cId="3818938006" sldId="271"/>
-            <ac:spMk id="25" creationId="{F9AADA9F-A5EA-8327-3871-106777A8D743}"/>
-          </ac:spMkLst>
-        </pc:spChg>
-        <pc:spChg chg="add mod">
-          <ac:chgData name="耀泉 马" userId="19e30af8d5659de2" providerId="LiveId" clId="{C3594856-CEDA-5129-B2AF-7962E3CA4CA3}" dt="2026-06-13T10:51:43.545" v="2882" actId="14100"/>
-          <ac:spMkLst>
-            <pc:docMk/>
-            <pc:sldMk cId="3818938006" sldId="271"/>
-            <ac:spMk id="32" creationId="{FCC746AE-51D8-DFFE-E159-802819D4F0D2}"/>
-          </ac:spMkLst>
-        </pc:spChg>
-        <pc:spChg chg="add mod">
-          <ac:chgData name="耀泉 马" userId="19e30af8d5659de2" providerId="LiveId" clId="{C3594856-CEDA-5129-B2AF-7962E3CA4CA3}" dt="2026-06-13T10:53:48.331" v="2896"/>
-          <ac:spMkLst>
-            <pc:docMk/>
-            <pc:sldMk cId="3818938006" sldId="271"/>
-            <ac:spMk id="33" creationId="{2980C993-E7F4-FCA0-1CBF-B3668C7B935C}"/>
-          </ac:spMkLst>
-        </pc:spChg>
-        <pc:spChg chg="add mod">
-          <ac:chgData name="耀泉 马" userId="19e30af8d5659de2" providerId="LiveId" clId="{C3594856-CEDA-5129-B2AF-7962E3CA4CA3}" dt="2026-06-13T10:45:28.770" v="2867" actId="1038"/>
-          <ac:spMkLst>
-            <pc:docMk/>
-            <pc:sldMk cId="3818938006" sldId="271"/>
-            <ac:spMk id="34" creationId="{4F43C31D-A821-FA32-8140-81B4BE0A6B6B}"/>
-          </ac:spMkLst>
-        </pc:spChg>
-        <pc:spChg chg="add mod">
-          <ac:chgData name="耀泉 马" userId="19e30af8d5659de2" providerId="LiveId" clId="{C3594856-CEDA-5129-B2AF-7962E3CA4CA3}" dt="2026-06-13T10:45:53.536" v="2876" actId="1038"/>
-          <ac:spMkLst>
-            <pc:docMk/>
-            <pc:sldMk cId="3818938006" sldId="271"/>
-            <ac:spMk id="35" creationId="{DFF04FD8-ADA6-8518-CAF7-84F9B0303799}"/>
-          </ac:spMkLst>
-        </pc:spChg>
-        <pc:spChg chg="add mod">
-          <ac:chgData name="耀泉 马" userId="19e30af8d5659de2" providerId="LiveId" clId="{C3594856-CEDA-5129-B2AF-7962E3CA4CA3}" dt="2026-06-13T10:43:24.578" v="2776" actId="14100"/>
-          <ac:spMkLst>
-            <pc:docMk/>
-            <pc:sldMk cId="3818938006" sldId="271"/>
-            <ac:spMk id="36" creationId="{642D2ECC-A90F-81A7-39F1-AA86F68C473E}"/>
-          </ac:spMkLst>
-        </pc:spChg>
-        <pc:spChg chg="add">
-          <ac:chgData name="耀泉 马" userId="19e30af8d5659de2" providerId="LiveId" clId="{C3594856-CEDA-5129-B2AF-7962E3CA4CA3}" dt="2026-06-13T10:43:00.867" v="2769" actId="11529"/>
-          <ac:spMkLst>
-            <pc:docMk/>
-            <pc:sldMk cId="3818938006" sldId="271"/>
-            <ac:spMk id="37" creationId="{69436A4E-805D-A244-5928-B1F6F400E6D2}"/>
-          </ac:spMkLst>
-        </pc:spChg>
-        <pc:spChg chg="add mod">
-          <ac:chgData name="耀泉 马" userId="19e30af8d5659de2" providerId="LiveId" clId="{C3594856-CEDA-5129-B2AF-7962E3CA4CA3}" dt="2026-06-13T10:52:28.862" v="2887" actId="20577"/>
-          <ac:spMkLst>
-            <pc:docMk/>
-            <pc:sldMk cId="3818938006" sldId="271"/>
-            <ac:spMk id="38" creationId="{D50F0F3B-AAA5-E3A3-5ABE-F0C994E00ACA}"/>
-          </ac:spMkLst>
-        </pc:spChg>
         <pc:spChg chg="mod">
-          <ac:chgData name="耀泉 马" userId="19e30af8d5659de2" providerId="LiveId" clId="{C3594856-CEDA-5129-B2AF-7962E3CA4CA3}" dt="2026-06-13T10:26:41.533" v="2601" actId="1036"/>
-          <ac:spMkLst>
-            <pc:docMk/>
-            <pc:sldMk cId="3818938006" sldId="271"/>
-            <ac:spMk id="94" creationId="{52AC2480-FA96-AE76-D468-0BF9136146D2}"/>
-          </ac:spMkLst>
-        </pc:spChg>
-        <pc:spChg chg="mod">
-          <ac:chgData name="耀泉 马" userId="19e30af8d5659de2" providerId="LiveId" clId="{C3594856-CEDA-5129-B2AF-7962E3CA4CA3}" dt="2026-06-13T10:26:41.533" v="2601" actId="1036"/>
-          <ac:spMkLst>
-            <pc:docMk/>
-            <pc:sldMk cId="3818938006" sldId="271"/>
-            <ac:spMk id="96" creationId="{14C6D9A8-E3BE-A3BF-EAE4-DCCD20CB3674}"/>
-          </ac:spMkLst>
-        </pc:spChg>
-        <pc:spChg chg="mod">
-          <ac:chgData name="耀泉 马" userId="19e30af8d5659de2" providerId="LiveId" clId="{C3594856-CEDA-5129-B2AF-7962E3CA4CA3}" dt="2026-06-13T10:26:41.533" v="2601" actId="1036"/>
-          <ac:spMkLst>
-            <pc:docMk/>
-            <pc:sldMk cId="3818938006" sldId="271"/>
-            <ac:spMk id="98" creationId="{07773818-3AC1-FA4C-E295-DF1844D6CFEF}"/>
-          </ac:spMkLst>
-        </pc:spChg>
-        <pc:spChg chg="mod">
-          <ac:chgData name="耀泉 马" userId="19e30af8d5659de2" providerId="LiveId" clId="{C3594856-CEDA-5129-B2AF-7962E3CA4CA3}" dt="2026-06-19T14:26:00.614" v="3887" actId="14100"/>
+          <ac:chgData name="耀泉 马" userId="19e30af8d5659de2" providerId="LiveId" clId="{C3594856-CEDA-5129-B2AF-7962E3CA4CA3}" dt="2026-08-29T15:05:49.399" v="3900" actId="14100"/>
           <ac:spMkLst>
             <pc:docMk/>
             <pc:sldMk cId="3818938006" sldId="271"/>
@@ -739,47 +182,7 @@
           </ac:spMkLst>
         </pc:spChg>
         <pc:spChg chg="mod">
-          <ac:chgData name="耀泉 马" userId="19e30af8d5659de2" providerId="LiveId" clId="{C3594856-CEDA-5129-B2AF-7962E3CA4CA3}" dt="2026-06-13T10:33:27.525" v="2605" actId="1076"/>
-          <ac:spMkLst>
-            <pc:docMk/>
-            <pc:sldMk cId="3818938006" sldId="271"/>
-            <ac:spMk id="100" creationId="{C8C51C22-74EC-BC2F-AB73-4AAE4EAE3B39}"/>
-          </ac:spMkLst>
-        </pc:spChg>
-        <pc:spChg chg="mod">
-          <ac:chgData name="耀泉 马" userId="19e30af8d5659de2" providerId="LiveId" clId="{C3594856-CEDA-5129-B2AF-7962E3CA4CA3}" dt="2026-06-13T10:26:41.533" v="2601" actId="1036"/>
-          <ac:spMkLst>
-            <pc:docMk/>
-            <pc:sldMk cId="3818938006" sldId="271"/>
-            <ac:spMk id="108" creationId="{0F97739D-F72F-CF7B-548C-7A50FAD71CF3}"/>
-          </ac:spMkLst>
-        </pc:spChg>
-        <pc:spChg chg="mod">
-          <ac:chgData name="耀泉 马" userId="19e30af8d5659de2" providerId="LiveId" clId="{C3594856-CEDA-5129-B2AF-7962E3CA4CA3}" dt="2026-06-13T10:26:41.533" v="2601" actId="1036"/>
-          <ac:spMkLst>
-            <pc:docMk/>
-            <pc:sldMk cId="3818938006" sldId="271"/>
-            <ac:spMk id="109" creationId="{0BF51883-933A-C1EB-C2F6-78ABDEAC4C09}"/>
-          </ac:spMkLst>
-        </pc:spChg>
-        <pc:spChg chg="mod">
-          <ac:chgData name="耀泉 马" userId="19e30af8d5659de2" providerId="LiveId" clId="{C3594856-CEDA-5129-B2AF-7962E3CA4CA3}" dt="2026-06-19T12:53:39.970" v="2912" actId="14100"/>
-          <ac:spMkLst>
-            <pc:docMk/>
-            <pc:sldMk cId="3818938006" sldId="271"/>
-            <ac:spMk id="110" creationId="{4345AF8C-7FC7-04F9-C4BF-EBFF1FF52189}"/>
-          </ac:spMkLst>
-        </pc:spChg>
-        <pc:spChg chg="mod">
-          <ac:chgData name="耀泉 马" userId="19e30af8d5659de2" providerId="LiveId" clId="{C3594856-CEDA-5129-B2AF-7962E3CA4CA3}" dt="2026-06-13T10:44:42.379" v="2849" actId="1035"/>
-          <ac:spMkLst>
-            <pc:docMk/>
-            <pc:sldMk cId="3818938006" sldId="271"/>
-            <ac:spMk id="111" creationId="{4497F59A-E9C7-8904-EC3E-B1F725E7BDC2}"/>
-          </ac:spMkLst>
-        </pc:spChg>
-        <pc:spChg chg="mod">
-          <ac:chgData name="耀泉 马" userId="19e30af8d5659de2" providerId="LiveId" clId="{C3594856-CEDA-5129-B2AF-7962E3CA4CA3}" dt="2026-06-19T12:53:28.371" v="2910" actId="1035"/>
+          <ac:chgData name="耀泉 马" userId="19e30af8d5659de2" providerId="LiveId" clId="{C3594856-CEDA-5129-B2AF-7962E3CA4CA3}" dt="2026-08-29T15:04:13.264" v="3899" actId="1036"/>
           <ac:spMkLst>
             <pc:docMk/>
             <pc:sldMk cId="3818938006" sldId="271"/>
@@ -787,79 +190,15 @@
           </ac:spMkLst>
         </pc:spChg>
         <pc:spChg chg="mod">
-          <ac:chgData name="耀泉 马" userId="19e30af8d5659de2" providerId="LiveId" clId="{C3594856-CEDA-5129-B2AF-7962E3CA4CA3}" dt="2026-06-19T12:53:28.371" v="2910" actId="1035"/>
+          <ac:chgData name="耀泉 马" userId="19e30af8d5659de2" providerId="LiveId" clId="{C3594856-CEDA-5129-B2AF-7962E3CA4CA3}" dt="2026-08-29T15:04:13.264" v="3899" actId="1036"/>
           <ac:spMkLst>
             <pc:docMk/>
             <pc:sldMk cId="3818938006" sldId="271"/>
             <ac:spMk id="119" creationId="{66331CAF-B02E-915B-AA87-EA61C9C6C789}"/>
           </ac:spMkLst>
         </pc:spChg>
-        <pc:spChg chg="mod">
-          <ac:chgData name="耀泉 马" userId="19e30af8d5659de2" providerId="LiveId" clId="{C3594856-CEDA-5129-B2AF-7962E3CA4CA3}" dt="2026-06-13T10:53:19.195" v="2893"/>
-          <ac:spMkLst>
-            <pc:docMk/>
-            <pc:sldMk cId="3818938006" sldId="271"/>
-            <ac:spMk id="137" creationId="{9F9DB95E-5AEB-EAD3-79F1-C02B7C9F1351}"/>
-          </ac:spMkLst>
-        </pc:spChg>
-        <pc:spChg chg="mod">
-          <ac:chgData name="耀泉 马" userId="19e30af8d5659de2" providerId="LiveId" clId="{C3594856-CEDA-5129-B2AF-7962E3CA4CA3}" dt="2026-06-13T10:45:01.493" v="2854" actId="1076"/>
-          <ac:spMkLst>
-            <pc:docMk/>
-            <pc:sldMk cId="3818938006" sldId="271"/>
-            <ac:spMk id="141" creationId="{FDC7B862-5B46-EBA3-2BF8-D040624A6821}"/>
-          </ac:spMkLst>
-        </pc:spChg>
-        <pc:spChg chg="mod">
-          <ac:chgData name="耀泉 马" userId="19e30af8d5659de2" providerId="LiveId" clId="{C3594856-CEDA-5129-B2AF-7962E3CA4CA3}" dt="2026-06-13T10:44:42.379" v="2849" actId="1035"/>
-          <ac:spMkLst>
-            <pc:docMk/>
-            <pc:sldMk cId="3818938006" sldId="271"/>
-            <ac:spMk id="142" creationId="{9D1B76DF-D298-C5AC-6DF6-924DB114C514}"/>
-          </ac:spMkLst>
-        </pc:spChg>
-        <pc:spChg chg="mod">
-          <ac:chgData name="耀泉 马" userId="19e30af8d5659de2" providerId="LiveId" clId="{C3594856-CEDA-5129-B2AF-7962E3CA4CA3}" dt="2026-06-13T10:44:42.379" v="2849" actId="1035"/>
-          <ac:spMkLst>
-            <pc:docMk/>
-            <pc:sldMk cId="3818938006" sldId="271"/>
-            <ac:spMk id="143" creationId="{24BD3EAE-6128-768D-4162-96DC06C8FAAA}"/>
-          </ac:spMkLst>
-        </pc:spChg>
-        <pc:spChg chg="mod">
-          <ac:chgData name="耀泉 马" userId="19e30af8d5659de2" providerId="LiveId" clId="{C3594856-CEDA-5129-B2AF-7962E3CA4CA3}" dt="2026-06-13T10:44:58.832" v="2853" actId="1076"/>
-          <ac:spMkLst>
-            <pc:docMk/>
-            <pc:sldMk cId="3818938006" sldId="271"/>
-            <ac:spMk id="147" creationId="{396A62E6-6DDD-391F-6E89-480383C9336A}"/>
-          </ac:spMkLst>
-        </pc:spChg>
-        <pc:picChg chg="add mod">
-          <ac:chgData name="耀泉 马" userId="19e30af8d5659de2" providerId="LiveId" clId="{C3594856-CEDA-5129-B2AF-7962E3CA4CA3}" dt="2026-06-13T10:15:21.807" v="2565" actId="1076"/>
-          <ac:picMkLst>
-            <pc:docMk/>
-            <pc:sldMk cId="3818938006" sldId="271"/>
-            <ac:picMk id="15" creationId="{7DF9D36E-E157-F30A-CCD4-18FDDC73432F}"/>
-          </ac:picMkLst>
-        </pc:picChg>
-        <pc:picChg chg="add mod">
-          <ac:chgData name="耀泉 马" userId="19e30af8d5659de2" providerId="LiveId" clId="{C3594856-CEDA-5129-B2AF-7962E3CA4CA3}" dt="2026-06-13T10:44:42.379" v="2849" actId="1035"/>
-          <ac:picMkLst>
-            <pc:docMk/>
-            <pc:sldMk cId="3818938006" sldId="271"/>
-            <ac:picMk id="19" creationId="{68A624BE-CEF4-851B-2C0C-142BBD04EF8C}"/>
-          </ac:picMkLst>
-        </pc:picChg>
         <pc:picChg chg="mod">
-          <ac:chgData name="耀泉 马" userId="19e30af8d5659de2" providerId="LiveId" clId="{C3594856-CEDA-5129-B2AF-7962E3CA4CA3}" dt="2026-06-13T10:03:43.882" v="2502" actId="1076"/>
-          <ac:picMkLst>
-            <pc:docMk/>
-            <pc:sldMk cId="3818938006" sldId="271"/>
-            <ac:picMk id="95" creationId="{67ED3F8A-8B8F-4625-C555-0B42A938DE4C}"/>
-          </ac:picMkLst>
-        </pc:picChg>
-        <pc:picChg chg="mod">
-          <ac:chgData name="耀泉 马" userId="19e30af8d5659de2" providerId="LiveId" clId="{C3594856-CEDA-5129-B2AF-7962E3CA4CA3}" dt="2026-06-19T12:53:28.371" v="2910" actId="1035"/>
+          <ac:chgData name="耀泉 马" userId="19e30af8d5659de2" providerId="LiveId" clId="{C3594856-CEDA-5129-B2AF-7962E3CA4CA3}" dt="2026-08-29T15:04:13.264" v="3899" actId="1036"/>
           <ac:picMkLst>
             <pc:docMk/>
             <pc:sldMk cId="3818938006" sldId="271"/>
@@ -867,90 +206,21 @@
           </ac:picMkLst>
         </pc:picChg>
         <pc:picChg chg="mod">
-          <ac:chgData name="耀泉 马" userId="19e30af8d5659de2" providerId="LiveId" clId="{C3594856-CEDA-5129-B2AF-7962E3CA4CA3}" dt="2026-06-19T12:53:28.371" v="2910" actId="1035"/>
+          <ac:chgData name="耀泉 马" userId="19e30af8d5659de2" providerId="LiveId" clId="{C3594856-CEDA-5129-B2AF-7962E3CA4CA3}" dt="2026-08-29T15:04:13.264" v="3899" actId="1036"/>
           <ac:picMkLst>
             <pc:docMk/>
             <pc:sldMk cId="3818938006" sldId="271"/>
             <ac:picMk id="117" creationId="{0E50EEC2-F282-83FB-B042-D41BC1ECC5A7}"/>
           </ac:picMkLst>
         </pc:picChg>
-        <pc:picChg chg="mod">
-          <ac:chgData name="耀泉 马" userId="19e30af8d5659de2" providerId="LiveId" clId="{C3594856-CEDA-5129-B2AF-7962E3CA4CA3}" dt="2026-06-13T10:44:42.379" v="2849" actId="1035"/>
-          <ac:picMkLst>
-            <pc:docMk/>
-            <pc:sldMk cId="3818938006" sldId="271"/>
-            <ac:picMk id="134" creationId="{B252CFF6-BC08-C166-6D2D-843DF72ED7FA}"/>
-          </ac:picMkLst>
-        </pc:picChg>
-        <pc:picChg chg="mod">
-          <ac:chgData name="耀泉 马" userId="19e30af8d5659de2" providerId="LiveId" clId="{C3594856-CEDA-5129-B2AF-7962E3CA4CA3}" dt="2026-06-13T10:45:04.064" v="2855" actId="1076"/>
-          <ac:picMkLst>
-            <pc:docMk/>
-            <pc:sldMk cId="3818938006" sldId="271"/>
-            <ac:picMk id="140" creationId="{1522A108-E33D-FA0D-F897-F14AA2DB801B}"/>
-          </ac:picMkLst>
-        </pc:picChg>
-        <pc:picChg chg="mod">
-          <ac:chgData name="耀泉 马" userId="19e30af8d5659de2" providerId="LiveId" clId="{C3594856-CEDA-5129-B2AF-7962E3CA4CA3}" dt="2026-06-13T10:39:12.914" v="2642" actId="1036"/>
-          <ac:picMkLst>
-            <pc:docMk/>
-            <pc:sldMk cId="3818938006" sldId="271"/>
-            <ac:picMk id="146" creationId="{7659E529-7FF8-4458-7E9E-2EEB3D58FCAF}"/>
-          </ac:picMkLst>
-        </pc:picChg>
-        <pc:picChg chg="mod">
-          <ac:chgData name="耀泉 马" userId="19e30af8d5659de2" providerId="LiveId" clId="{C3594856-CEDA-5129-B2AF-7962E3CA4CA3}" dt="2026-06-13T10:26:41.533" v="2601" actId="1036"/>
-          <ac:picMkLst>
-            <pc:docMk/>
-            <pc:sldMk cId="3818938006" sldId="271"/>
-            <ac:picMk id="201" creationId="{9237C914-A3C1-BBE5-D3FF-68F44FA5FEC4}"/>
-          </ac:picMkLst>
-        </pc:picChg>
-        <pc:cxnChg chg="add mod">
-          <ac:chgData name="耀泉 马" userId="19e30af8d5659de2" providerId="LiveId" clId="{C3594856-CEDA-5129-B2AF-7962E3CA4CA3}" dt="2026-06-13T10:45:48.075" v="2871" actId="1037"/>
-          <ac:cxnSpMkLst>
-            <pc:docMk/>
-            <pc:sldMk cId="3818938006" sldId="271"/>
-            <ac:cxnSpMk id="31" creationId="{C0BB1A85-1098-ADD2-7F1E-FEEB7471E036}"/>
-          </ac:cxnSpMkLst>
-        </pc:cxnChg>
         <pc:cxnChg chg="mod">
-          <ac:chgData name="耀泉 马" userId="19e30af8d5659de2" providerId="LiveId" clId="{C3594856-CEDA-5129-B2AF-7962E3CA4CA3}" dt="2026-06-19T12:53:39.970" v="2912" actId="14100"/>
+          <ac:chgData name="耀泉 马" userId="19e30af8d5659de2" providerId="LiveId" clId="{C3594856-CEDA-5129-B2AF-7962E3CA4CA3}" dt="2026-08-29T15:04:13.264" v="3899" actId="1036"/>
           <ac:cxnSpMkLst>
             <pc:docMk/>
             <pc:sldMk cId="3818938006" sldId="271"/>
             <ac:cxnSpMk id="127" creationId="{B475213A-4FA8-0889-07CA-E7D0B82C2E2F}"/>
           </ac:cxnSpMkLst>
         </pc:cxnChg>
-      </pc:sldChg>
-      <pc:sldChg chg="modSp add mod">
-        <pc:chgData name="耀泉 马" userId="19e30af8d5659de2" providerId="LiveId" clId="{C3594856-CEDA-5129-B2AF-7962E3CA4CA3}" dt="2026-06-19T13:02:05.169" v="2926" actId="1076"/>
-        <pc:sldMkLst>
-          <pc:docMk/>
-          <pc:sldMk cId="2021610009" sldId="272"/>
-        </pc:sldMkLst>
-        <pc:spChg chg="mod">
-          <ac:chgData name="耀泉 马" userId="19e30af8d5659de2" providerId="LiveId" clId="{C3594856-CEDA-5129-B2AF-7962E3CA4CA3}" dt="2026-06-19T13:02:05.169" v="2926" actId="1076"/>
-          <ac:spMkLst>
-            <pc:docMk/>
-            <pc:sldMk cId="2021610009" sldId="272"/>
-            <ac:spMk id="100" creationId="{67C919DC-A6AB-EE16-42E4-D6D9F6B359A4}"/>
-          </ac:spMkLst>
-        </pc:spChg>
-      </pc:sldChg>
-      <pc:sldChg chg="add">
-        <pc:chgData name="耀泉 马" userId="19e30af8d5659de2" providerId="LiveId" clId="{C3594856-CEDA-5129-B2AF-7962E3CA4CA3}" dt="2026-06-19T13:01:04.075" v="2916"/>
-        <pc:sldMkLst>
-          <pc:docMk/>
-          <pc:sldMk cId="1171882994" sldId="273"/>
-        </pc:sldMkLst>
-      </pc:sldChg>
-      <pc:sldChg chg="add">
-        <pc:chgData name="耀泉 马" userId="19e30af8d5659de2" providerId="LiveId" clId="{C3594856-CEDA-5129-B2AF-7962E3CA4CA3}" dt="2026-06-19T14:28:49.154" v="3889"/>
-        <pc:sldMkLst>
-          <pc:docMk/>
-          <pc:sldMk cId="4130449483" sldId="274"/>
-        </pc:sldMkLst>
       </pc:sldChg>
     </pc:docChg>
   </pc:docChgLst>
@@ -1039,7 +309,7 @@
           <a:p>
             <a:fld id="{8BCF708F-C5DA-2442-B459-317C43B6759F}" type="datetimeFigureOut">
               <a:rPr lang="en-US" smtClean="0"/>
-              <a:t>6/19/26</a:t>
+              <a:t>8/29/26</a:t>
             </a:fld>
             <a:endParaRPr lang="en-US"/>
           </a:p>
@@ -3015,7 +2285,7 @@
           <a:p>
             <a:fld id="{0FA3F8E0-39CC-F548-AAA7-4485C47B7E6B}" type="datetimeFigureOut">
               <a:rPr lang="en-US" smtClean="0"/>
-              <a:t>6/19/26</a:t>
+              <a:t>8/29/26</a:t>
             </a:fld>
             <a:endParaRPr lang="en-US"/>
           </a:p>
@@ -3215,7 +2485,7 @@
           <a:p>
             <a:fld id="{0FA3F8E0-39CC-F548-AAA7-4485C47B7E6B}" type="datetimeFigureOut">
               <a:rPr lang="en-US" smtClean="0"/>
-              <a:t>6/19/26</a:t>
+              <a:t>8/29/26</a:t>
             </a:fld>
             <a:endParaRPr lang="en-US"/>
           </a:p>
@@ -3425,7 +2695,7 @@
           <a:p>
             <a:fld id="{0FA3F8E0-39CC-F548-AAA7-4485C47B7E6B}" type="datetimeFigureOut">
               <a:rPr lang="en-US" smtClean="0"/>
-              <a:t>6/19/26</a:t>
+              <a:t>8/29/26</a:t>
             </a:fld>
             <a:endParaRPr lang="en-US"/>
           </a:p>
@@ -3625,7 +2895,7 @@
           <a:p>
             <a:fld id="{0FA3F8E0-39CC-F548-AAA7-4485C47B7E6B}" type="datetimeFigureOut">
               <a:rPr lang="en-US" smtClean="0"/>
-              <a:t>6/19/26</a:t>
+              <a:t>8/29/26</a:t>
             </a:fld>
             <a:endParaRPr lang="en-US"/>
           </a:p>
@@ -3901,7 +3171,7 @@
           <a:p>
             <a:fld id="{0FA3F8E0-39CC-F548-AAA7-4485C47B7E6B}" type="datetimeFigureOut">
               <a:rPr lang="en-US" smtClean="0"/>
-              <a:t>6/19/26</a:t>
+              <a:t>8/29/26</a:t>
             </a:fld>
             <a:endParaRPr lang="en-US"/>
           </a:p>
@@ -4169,7 +3439,7 @@
           <a:p>
             <a:fld id="{0FA3F8E0-39CC-F548-AAA7-4485C47B7E6B}" type="datetimeFigureOut">
               <a:rPr lang="en-US" smtClean="0"/>
-              <a:t>6/19/26</a:t>
+              <a:t>8/29/26</a:t>
             </a:fld>
             <a:endParaRPr lang="en-US"/>
           </a:p>
@@ -4584,7 +3854,7 @@
           <a:p>
             <a:fld id="{0FA3F8E0-39CC-F548-AAA7-4485C47B7E6B}" type="datetimeFigureOut">
               <a:rPr lang="en-US" smtClean="0"/>
-              <a:t>6/19/26</a:t>
+              <a:t>8/29/26</a:t>
             </a:fld>
             <a:endParaRPr lang="en-US"/>
           </a:p>
@@ -4726,7 +3996,7 @@
           <a:p>
             <a:fld id="{0FA3F8E0-39CC-F548-AAA7-4485C47B7E6B}" type="datetimeFigureOut">
               <a:rPr lang="en-US" smtClean="0"/>
-              <a:t>6/19/26</a:t>
+              <a:t>8/29/26</a:t>
             </a:fld>
             <a:endParaRPr lang="en-US"/>
           </a:p>
@@ -4839,7 +4109,7 @@
           <a:p>
             <a:fld id="{0FA3F8E0-39CC-F548-AAA7-4485C47B7E6B}" type="datetimeFigureOut">
               <a:rPr lang="en-US" smtClean="0"/>
-              <a:t>6/19/26</a:t>
+              <a:t>8/29/26</a:t>
             </a:fld>
             <a:endParaRPr lang="en-US"/>
           </a:p>
@@ -5152,7 +4422,7 @@
           <a:p>
             <a:fld id="{0FA3F8E0-39CC-F548-AAA7-4485C47B7E6B}" type="datetimeFigureOut">
               <a:rPr lang="en-US" smtClean="0"/>
-              <a:t>6/19/26</a:t>
+              <a:t>8/29/26</a:t>
             </a:fld>
             <a:endParaRPr lang="en-US"/>
           </a:p>
@@ -5441,7 +4711,7 @@
           <a:p>
             <a:fld id="{0FA3F8E0-39CC-F548-AAA7-4485C47B7E6B}" type="datetimeFigureOut">
               <a:rPr lang="en-US" smtClean="0"/>
-              <a:t>6/19/26</a:t>
+              <a:t>8/29/26</a:t>
             </a:fld>
             <a:endParaRPr lang="en-US"/>
           </a:p>
@@ -5684,7 +4954,7 @@
           <a:p>
             <a:fld id="{0FA3F8E0-39CC-F548-AAA7-4485C47B7E6B}" type="datetimeFigureOut">
               <a:rPr lang="en-US" smtClean="0"/>
-              <a:t>6/19/26</a:t>
+              <a:t>8/29/26</a:t>
             </a:fld>
             <a:endParaRPr lang="en-US"/>
           </a:p>
@@ -17189,8 +16459,8 @@
         </p:nvSpPr>
         <p:spPr>
           <a:xfrm>
-            <a:off x="457201" y="113729"/>
-            <a:ext cx="6236144" cy="5954638"/>
+            <a:off x="457201" y="248200"/>
+            <a:ext cx="6236144" cy="6381986"/>
           </a:xfrm>
           <a:prstGeom prst="roundRect">
             <a:avLst>
@@ -17864,7 +17134,7 @@
         </p:blipFill>
         <p:spPr>
           <a:xfrm>
-            <a:off x="4191470" y="4317151"/>
+            <a:off x="4191470" y="4397836"/>
             <a:ext cx="941817" cy="941817"/>
           </a:xfrm>
           <a:prstGeom prst="rect">
@@ -17886,7 +17156,7 @@
         </p:nvSpPr>
         <p:spPr>
           <a:xfrm>
-            <a:off x="3994147" y="3983393"/>
+            <a:off x="3994147" y="4064078"/>
             <a:ext cx="2646607" cy="276999"/>
           </a:xfrm>
           <a:prstGeom prst="rect">
@@ -17929,7 +17199,7 @@
         </p:blipFill>
         <p:spPr>
           <a:xfrm>
-            <a:off x="5422622" y="4322961"/>
+            <a:off x="5422622" y="4403646"/>
             <a:ext cx="907873" cy="907873"/>
           </a:xfrm>
           <a:prstGeom prst="rect">
@@ -17951,7 +17221,7 @@
         </p:nvSpPr>
         <p:spPr>
           <a:xfrm>
-            <a:off x="5075428" y="4410168"/>
+            <a:off x="5075428" y="4490853"/>
             <a:ext cx="844062" cy="830997"/>
           </a:xfrm>
           <a:prstGeom prst="rect">
@@ -17991,8 +17261,8 @@
         </p:nvCxnSpPr>
         <p:spPr>
           <a:xfrm rot="10800000">
-            <a:off x="6330495" y="4776899"/>
-            <a:ext cx="1087562" cy="82061"/>
+            <a:off x="6330495" y="4857583"/>
+            <a:ext cx="1087562" cy="1376"/>
           </a:xfrm>
           <a:prstGeom prst="bentConnector3">
             <a:avLst>

</xml_diff>